<commit_message>
data-eng: 3-1 덱 5개(w3d1s0 신설·s1~s4 pandas 3 표기) · 부록 재빌드(pandas 2/3 dtype 항목)
</commit_message>
<xml_diff>
--- a/data-eng/decks/w3d1s1.pptx
+++ b/data-eng/decks/w3d1s1.pptx
@@ -3100,7 +3100,7 @@
       <p:grpSpPr/>
       <p:sp>
         <p:nvSpPr>
-          <p:cNvPr id="2" name="Oval 1"/>
+          <p:cNvPr id="2" name="deckgen:decor"/>
           <p:cNvSpPr/>
           <p:nvPr/>
         </p:nvSpPr>
@@ -3130,7 +3130,7 @@
       </p:sp>
       <p:sp>
         <p:nvSpPr>
-          <p:cNvPr id="3" name="Oval 2"/>
+          <p:cNvPr id="3" name="deckgen:decor"/>
           <p:cNvSpPr/>
           <p:nvPr/>
         </p:nvSpPr>
@@ -3160,7 +3160,7 @@
       </p:sp>
       <p:sp>
         <p:nvSpPr>
-          <p:cNvPr id="4" name="Oval 3"/>
+          <p:cNvPr id="4" name="deckgen:decor"/>
           <p:cNvSpPr/>
           <p:nvPr/>
         </p:nvSpPr>
@@ -3190,7 +3190,7 @@
       </p:sp>
       <p:sp>
         <p:nvSpPr>
-          <p:cNvPr id="5" name="Rectangle 4"/>
+          <p:cNvPr id="5" name="deckgen:decor"/>
           <p:cNvSpPr/>
           <p:nvPr/>
         </p:nvSpPr>
@@ -3220,7 +3220,7 @@
       </p:sp>
       <p:sp>
         <p:nvSpPr>
-          <p:cNvPr id="6" name="Oval 5"/>
+          <p:cNvPr id="6" name="deckgen:decor"/>
           <p:cNvSpPr/>
           <p:nvPr/>
         </p:nvSpPr>
@@ -3250,7 +3250,7 @@
       </p:sp>
       <p:sp>
         <p:nvSpPr>
-          <p:cNvPr id="7" name="Oval 6"/>
+          <p:cNvPr id="7" name="deckgen:decor"/>
           <p:cNvSpPr/>
           <p:nvPr/>
         </p:nvSpPr>
@@ -3280,7 +3280,7 @@
       </p:sp>
       <p:sp>
         <p:nvSpPr>
-          <p:cNvPr id="8" name="Oval 7"/>
+          <p:cNvPr id="8" name="deckgen:decor"/>
           <p:cNvSpPr/>
           <p:nvPr/>
         </p:nvSpPr>
@@ -3310,7 +3310,7 @@
       </p:sp>
       <p:sp>
         <p:nvSpPr>
-          <p:cNvPr id="9" name="Oval 8"/>
+          <p:cNvPr id="9" name="deckgen:decor"/>
           <p:cNvSpPr/>
           <p:nvPr/>
         </p:nvSpPr>
@@ -3340,7 +3340,7 @@
       </p:sp>
       <p:sp>
         <p:nvSpPr>
-          <p:cNvPr id="10" name="Rectangle 9"/>
+          <p:cNvPr id="10" name="deckgen:decor"/>
           <p:cNvSpPr/>
           <p:nvPr/>
         </p:nvSpPr>
@@ -3600,7 +3600,7 @@
       <p:grpSpPr/>
       <p:sp>
         <p:nvSpPr>
-          <p:cNvPr id="2" name="Oval 1"/>
+          <p:cNvPr id="2" name="deckgen:decor"/>
           <p:cNvSpPr/>
           <p:nvPr/>
         </p:nvSpPr>
@@ -3630,7 +3630,7 @@
       </p:sp>
       <p:sp>
         <p:nvSpPr>
-          <p:cNvPr id="3" name="Oval 2"/>
+          <p:cNvPr id="3" name="deckgen:decor"/>
           <p:cNvSpPr/>
           <p:nvPr/>
         </p:nvSpPr>
@@ -3660,7 +3660,7 @@
       </p:sp>
       <p:sp>
         <p:nvSpPr>
-          <p:cNvPr id="4" name="Oval 3"/>
+          <p:cNvPr id="4" name="deckgen:decor"/>
           <p:cNvSpPr/>
           <p:nvPr/>
         </p:nvSpPr>
@@ -4662,7 +4662,7 @@
       <p:grpSpPr/>
       <p:sp>
         <p:nvSpPr>
-          <p:cNvPr id="2" name="Oval 1"/>
+          <p:cNvPr id="2" name="deckgen:decor"/>
           <p:cNvSpPr/>
           <p:nvPr/>
         </p:nvSpPr>
@@ -4692,7 +4692,7 @@
       </p:sp>
       <p:sp>
         <p:nvSpPr>
-          <p:cNvPr id="3" name="Oval 2"/>
+          <p:cNvPr id="3" name="deckgen:decor"/>
           <p:cNvSpPr/>
           <p:nvPr/>
         </p:nvSpPr>
@@ -5469,7 +5469,7 @@
       <p:grpSpPr/>
       <p:sp>
         <p:nvSpPr>
-          <p:cNvPr id="2" name="Oval 1"/>
+          <p:cNvPr id="2" name="deckgen:decor"/>
           <p:cNvSpPr/>
           <p:nvPr/>
         </p:nvSpPr>
@@ -5499,7 +5499,7 @@
       </p:sp>
       <p:sp>
         <p:nvSpPr>
-          <p:cNvPr id="3" name="Oval 2"/>
+          <p:cNvPr id="3" name="deckgen:decor"/>
           <p:cNvSpPr/>
           <p:nvPr/>
         </p:nvSpPr>
@@ -5529,7 +5529,7 @@
       </p:sp>
       <p:sp>
         <p:nvSpPr>
-          <p:cNvPr id="4" name="Oval 3"/>
+          <p:cNvPr id="4" name="deckgen:decor"/>
           <p:cNvSpPr/>
           <p:nvPr/>
         </p:nvSpPr>
@@ -6460,7 +6460,7 @@
       <p:grpSpPr/>
       <p:sp>
         <p:nvSpPr>
-          <p:cNvPr id="2" name="Oval 1"/>
+          <p:cNvPr id="2" name="deckgen:decor"/>
           <p:cNvSpPr/>
           <p:nvPr/>
         </p:nvSpPr>
@@ -6490,7 +6490,7 @@
       </p:sp>
       <p:sp>
         <p:nvSpPr>
-          <p:cNvPr id="3" name="Oval 2"/>
+          <p:cNvPr id="3" name="deckgen:decor"/>
           <p:cNvSpPr/>
           <p:nvPr/>
         </p:nvSpPr>
@@ -6520,7 +6520,7 @@
       </p:sp>
       <p:sp>
         <p:nvSpPr>
-          <p:cNvPr id="4" name="Oval 3"/>
+          <p:cNvPr id="4" name="deckgen:decor"/>
           <p:cNvSpPr/>
           <p:nvPr/>
         </p:nvSpPr>
@@ -7460,7 +7460,7 @@
       <p:grpSpPr/>
       <p:sp>
         <p:nvSpPr>
-          <p:cNvPr id="2" name="Oval 1"/>
+          <p:cNvPr id="2" name="deckgen:decor"/>
           <p:cNvSpPr/>
           <p:nvPr/>
         </p:nvSpPr>
@@ -7490,7 +7490,7 @@
       </p:sp>
       <p:sp>
         <p:nvSpPr>
-          <p:cNvPr id="3" name="Oval 2"/>
+          <p:cNvPr id="3" name="deckgen:decor"/>
           <p:cNvSpPr/>
           <p:nvPr/>
         </p:nvSpPr>
@@ -7520,7 +7520,7 @@
       </p:sp>
       <p:sp>
         <p:nvSpPr>
-          <p:cNvPr id="4" name="Oval 3"/>
+          <p:cNvPr id="4" name="deckgen:decor"/>
           <p:cNvSpPr/>
           <p:nvPr/>
         </p:nvSpPr>
@@ -8946,7 +8946,7 @@
       <p:grpSpPr/>
       <p:sp>
         <p:nvSpPr>
-          <p:cNvPr id="2" name="Oval 1"/>
+          <p:cNvPr id="2" name="deckgen:decor"/>
           <p:cNvSpPr/>
           <p:nvPr/>
         </p:nvSpPr>
@@ -8976,7 +8976,7 @@
       </p:sp>
       <p:sp>
         <p:nvSpPr>
-          <p:cNvPr id="3" name="Oval 2"/>
+          <p:cNvPr id="3" name="deckgen:decor"/>
           <p:cNvSpPr/>
           <p:nvPr/>
         </p:nvSpPr>
@@ -9006,7 +9006,7 @@
       </p:sp>
       <p:sp>
         <p:nvSpPr>
-          <p:cNvPr id="4" name="Oval 3"/>
+          <p:cNvPr id="4" name="deckgen:decor"/>
           <p:cNvSpPr/>
           <p:nvPr/>
         </p:nvSpPr>
@@ -10044,7 +10044,7 @@
       <p:grpSpPr/>
       <p:sp>
         <p:nvSpPr>
-          <p:cNvPr id="2" name="Oval 1"/>
+          <p:cNvPr id="2" name="deckgen:decor"/>
           <p:cNvSpPr/>
           <p:nvPr/>
         </p:nvSpPr>
@@ -10074,7 +10074,7 @@
       </p:sp>
       <p:sp>
         <p:nvSpPr>
-          <p:cNvPr id="3" name="Oval 2"/>
+          <p:cNvPr id="3" name="deckgen:decor"/>
           <p:cNvSpPr/>
           <p:nvPr/>
         </p:nvSpPr>
@@ -10104,7 +10104,7 @@
       </p:sp>
       <p:sp>
         <p:nvSpPr>
-          <p:cNvPr id="4" name="Oval 3"/>
+          <p:cNvPr id="4" name="deckgen:decor"/>
           <p:cNvSpPr/>
           <p:nvPr/>
         </p:nvSpPr>
@@ -10977,7 +10977,7 @@
                 <a:ea typeface="Pretendard"/>
                 <a:cs typeface="Pretendard"/>
               </a:rPr>
-              <a:t>object</a:t>
+              <a:t>str (pandas 2: object)</a:t>
             </a:r>
           </a:p>
         </p:txBody>
@@ -11202,7 +11202,7 @@
                 <a:ea typeface="Pretendard"/>
                 <a:cs typeface="Pretendard"/>
               </a:rPr>
-              <a:t>datetime64[ns]</a:t>
+              <a:t>datetime64[us]</a:t>
             </a:r>
           </a:p>
         </p:txBody>
@@ -11980,7 +11980,7 @@
       <p:grpSpPr/>
       <p:sp>
         <p:nvSpPr>
-          <p:cNvPr id="2" name="Oval 1"/>
+          <p:cNvPr id="2" name="deckgen:decor"/>
           <p:cNvSpPr/>
           <p:nvPr/>
         </p:nvSpPr>
@@ -12010,7 +12010,7 @@
       </p:sp>
       <p:sp>
         <p:nvSpPr>
-          <p:cNvPr id="3" name="Oval 2"/>
+          <p:cNvPr id="3" name="deckgen:decor"/>
           <p:cNvSpPr/>
           <p:nvPr/>
         </p:nvSpPr>
@@ -12040,7 +12040,7 @@
       </p:sp>
       <p:sp>
         <p:nvSpPr>
-          <p:cNvPr id="4" name="Oval 3"/>
+          <p:cNvPr id="4" name="deckgen:decor"/>
           <p:cNvSpPr/>
           <p:nvPr/>
         </p:nvSpPr>
@@ -13078,7 +13078,7 @@
       <p:grpSpPr/>
       <p:sp>
         <p:nvSpPr>
-          <p:cNvPr id="2" name="Oval 1"/>
+          <p:cNvPr id="2" name="deckgen:decor"/>
           <p:cNvSpPr/>
           <p:nvPr/>
         </p:nvSpPr>
@@ -13108,7 +13108,7 @@
       </p:sp>
       <p:sp>
         <p:nvSpPr>
-          <p:cNvPr id="3" name="Oval 2"/>
+          <p:cNvPr id="3" name="deckgen:decor"/>
           <p:cNvSpPr/>
           <p:nvPr/>
         </p:nvSpPr>
@@ -13138,7 +13138,7 @@
       </p:sp>
       <p:sp>
         <p:nvSpPr>
-          <p:cNvPr id="4" name="Oval 3"/>
+          <p:cNvPr id="4" name="deckgen:decor"/>
           <p:cNvSpPr/>
           <p:nvPr/>
         </p:nvSpPr>
@@ -14139,7 +14139,7 @@
       <p:grpSpPr/>
       <p:sp>
         <p:nvSpPr>
-          <p:cNvPr id="2" name="Oval 1"/>
+          <p:cNvPr id="2" name="deckgen:decor"/>
           <p:cNvSpPr/>
           <p:nvPr/>
         </p:nvSpPr>
@@ -14169,7 +14169,7 @@
       </p:sp>
       <p:sp>
         <p:nvSpPr>
-          <p:cNvPr id="3" name="Oval 2"/>
+          <p:cNvPr id="3" name="deckgen:decor"/>
           <p:cNvSpPr/>
           <p:nvPr/>
         </p:nvSpPr>
@@ -14199,7 +14199,7 @@
       </p:sp>
       <p:sp>
         <p:nvSpPr>
-          <p:cNvPr id="4" name="Oval 3"/>
+          <p:cNvPr id="4" name="deckgen:decor"/>
           <p:cNvSpPr/>
           <p:nvPr/>
         </p:nvSpPr>

</xml_diff>

<commit_message>
data-eng: 3-1 덱 점검 반영(amount 결측·venv 켜기·[ns] 병기)
</commit_message>
<xml_diff>
--- a/data-eng/decks/w3d1s1.pptx
+++ b/data-eng/decks/w3d1s1.pptx
@@ -4984,7 +4984,7 @@
                 <a:ea typeface="Pretendard"/>
                 <a:cs typeface="Pretendard"/>
               </a:rPr>
-              <a:t>venv 만들고 pandas·pyarrow 설치</a:t>
+              <a:t>실습점검의 venv 켜고 pandas 3 확인</a:t>
             </a:r>
           </a:p>
         </p:txBody>
@@ -11194,7 +11194,7 @@
               </a:lnSpc>
             </a:pPr>
             <a:r>
-              <a:rPr sz="1875" b="1">
+              <a:rPr sz="1650" b="1">
                 <a:solidFill>
                   <a:srgbClr val="0D2B5E"/>
                 </a:solidFill>
@@ -11202,7 +11202,7 @@
                 <a:ea typeface="Pretendard"/>
                 <a:cs typeface="Pretendard"/>
               </a:rPr>
-              <a:t>datetime64[us]</a:t>
+              <a:t>datetime64[us] (pandas 2: [ns])</a:t>
             </a:r>
           </a:p>
         </p:txBody>

</xml_diff>